<commit_message>
Organize the 拓殖大学 fill-in sheet by admission-policy item
- STEP 2 asks for self-PR material per item: founding philosophy,
  faculty policy, department goal, (1)-(3)
- Add the 政経学部 faculty-level policy to the sheet and slides
- Add three 20x20 原稿用紙 sheets with 900/1000-char marks

Co-Authored-By: Claude Opus 5.5 <noreply@anthropic.com>
Claude-Session: https://claude.ai/code/session_018XciJJW37X4j1Si7AWU6FS
</commit_message>
<xml_diff>
--- a/小論文添削（ショー）/ワークシート/拓殖大学_政経学部法律政治学科/拓殖大学_政経学部法律政治学科_小論文ワークシート.pptx
+++ b/小論文添削（ショー）/ワークシート/拓殖大学_政経学部法律政治学科/拓殖大学_政経学部法律政治学科_小論文ワークシート.pptx
@@ -18652,7 +18652,7 @@
                 <a:latin typeface="游ゴシック"/>
                 <a:ea typeface="游ゴシック"/>
               </a:rPr>
-              <a:t>✓ 建学の理念とAPの言葉を両方使ったか</a:t>
+              <a:t>✓ 建学の理念と学部・学科のAPを使ったか</a:t>
             </a:r>
           </a:p>
           <a:p>
@@ -23309,7 +23309,7 @@
               </a:spcAft>
             </a:pPr>
             <a:r>
-              <a:rPr sz="1350" b="1">
+              <a:rPr sz="1450" b="1">
                 <a:solidFill>
                   <a:srgbClr val="2C5F2D"/>
                 </a:solidFill>
@@ -23329,14 +23329,14 @@
               </a:spcAft>
             </a:pPr>
             <a:r>
-              <a:rPr sz="1350" b="0">
+              <a:rPr sz="1450" b="0">
                 <a:solidFill>
                   <a:srgbClr val="23301F"/>
                 </a:solidFill>
                 <a:latin typeface="游ゴシック"/>
                 <a:ea typeface="游ゴシック"/>
               </a:rPr>
-              <a:t>建学の理念：「積極進取の気概とあらゆる民族から敬慕されるに値する教養と品格を具えた有為な人材の育成」。今の言い方では、国際的な視野を持ち、何事にも積極的にチャレンジし、国内外の人と協働して問題を解決できる人材（拓殖人材）。法律政治学科のAP：法律学・政治学の知識で実社会の諸問題を指摘・解決する力を修得する。グローバル化への関心と論理的思考力、社会現象への関心と行動力、地域・グローバル社会を支える志。</a:t>
+              <a:t>建学の理念：「積極進取の気概とあらゆる民族から敬慕されるに値する教養と品格を具えた有為な人材の育成」（拓殖人材）。政経学部のAP：他者と協働しながら現場で課題に対処する意欲、グローバリゼーションへの関心、論理的思考力、社会現象への関心と行動力。留学・ボランティア等も評価。法律政治学科のAP：法律学・政治学の知識で実社会の問題を解決する力、地域・グローバル社会を支える志。</a:t>
             </a:r>
           </a:p>
         </p:txBody>
@@ -24595,7 +24595,7 @@
                   <a:latin typeface="游ゴシック"/>
                   <a:ea typeface="游ゴシック"/>
                 </a:rPr>
-                <a:t>大学は「協働して問題を解決する人材」、学科は「社会の問題を解決する力」を求めている</a:t>
+                <a:t>大学は「協働して問題を解決する人材」、学部・学科は「現場で課題に対処し解決する力」を求めている</a:t>
               </a:r>
             </a:p>
           </p:txBody>

</xml_diff>

<commit_message>
Use official Takushoku admission-policy wording in the worksheets
Read directly from takudai.jp and takushoku-u.ac.jp (2027 entrance
version). Sheet sections 1-1 to 1-3 and STEP 2 items now quote the
original text; slide material and model-answer quotes match it.

Co-Authored-By: Claude Opus 5.5 <noreply@anthropic.com>
Claude-Session: https://claude.ai/code/session_018XciJJW37X4j1Si7AWU6FS
</commit_message>
<xml_diff>
--- a/小論文添削（ショー）/ワークシート/拓殖大学_政経学部法律政治学科/拓殖大学_政経学部法律政治学科_小論文ワークシート.pptx
+++ b/小論文添削（ショー）/ワークシート/拓殖大学_政経学部法律政治学科/拓殖大学_政経学部法律政治学科_小論文ワークシート.pptx
@@ -3754,7 +3754,7 @@
                 <a:latin typeface="游ゴシック"/>
                 <a:ea typeface="游ゴシック"/>
               </a:rPr>
-              <a:t>合計994字（序論148・本論①305・本論②206・本論③179・結論156）</a:t>
+              <a:t>合計969字（序論161・本論①305・本論②210・本論③137・結論156）</a:t>
             </a:r>
           </a:p>
         </p:txBody>
@@ -3872,7 +3872,7 @@
         <p:spPr>
           <a:xfrm>
             <a:off x="1783080" y="1847088"/>
-            <a:ext cx="9674352" cy="723519"/>
+            <a:ext cx="9674352" cy="946404"/>
           </a:xfrm>
           <a:prstGeom prst="rect">
             <a:avLst/>
@@ -3902,7 +3902,7 @@
                 <a:latin typeface="游ゴシック"/>
                 <a:ea typeface="游ゴシック"/>
               </a:rPr>
-              <a:t>私の強みは、立場の違う人の意見を聞き、話し合いによって課題を解決へ導く力である。この力は、貴学が育成をめざす「国内外の人と協働して問題を解決できる人材」に通じるものだと考える。私はこの強みを法律学・政治学の学びによってさらに磨き、社会のルールづくりに携わる人間になりたいと考え、貴学科を志望する。</a:t>
+              <a:t>私の強みは、立場の違う人の意見を聞き、話し合いによって課題を解決へ導く力である。この力は、貴学がめざす「国内外の人々と協働して積極的に課題の発見と解決にチャレンジしていく」人材像に通じるものだと考える。私はこの強みを法律学・政治学の学びによってさらに磨き、社会のルールづくりに携わる人間になりたいと考え、貴学科を志望する。</a:t>
             </a:r>
           </a:p>
         </p:txBody>
@@ -3915,7 +3915,7 @@
         </p:nvSpPr>
         <p:spPr>
           <a:xfrm>
-            <a:off x="704088" y="2671191"/>
+            <a:off x="704088" y="2894076"/>
             <a:ext cx="914400" cy="365760"/>
           </a:xfrm>
           <a:prstGeom prst="roundRect">
@@ -3971,7 +3971,7 @@
         </p:nvSpPr>
         <p:spPr>
           <a:xfrm>
-            <a:off x="1783080" y="2634615"/>
+            <a:off x="1783080" y="2857500"/>
             <a:ext cx="9674352" cy="1392174"/>
           </a:xfrm>
           <a:prstGeom prst="rect">
@@ -4440,7 +4440,7 @@
                 <a:latin typeface="游ゴシック"/>
                 <a:ea typeface="游ゴシック"/>
               </a:rPr>
-              <a:t>合計994字（序論148・本論①305・本論②206・本論③179・結論156）</a:t>
+              <a:t>合計969字（序論161・本論①305・本論②210・本論③137・結論156）</a:t>
             </a:r>
           </a:p>
         </p:txBody>
@@ -4558,7 +4558,7 @@
         <p:spPr>
           <a:xfrm>
             <a:off x="1783080" y="1847088"/>
-            <a:ext cx="9674352" cy="946404"/>
+            <a:ext cx="9674352" cy="1169289"/>
           </a:xfrm>
           <a:prstGeom prst="rect">
             <a:avLst/>
@@ -4588,7 +4588,7 @@
                 <a:latin typeface="游ゴシック"/>
                 <a:ea typeface="游ゴシック"/>
               </a:rPr>
-              <a:t>この経験から私が学んだのは、ルールは一方的に押し付けるものではなく、異なる立場の人々が納得できるよう話し合ってつくるものだということである。貴学の建学の精神にある「積極進取の気概」と「教養と品格」は、自ら課題に向き合い、相手を尊重しながら合意を探る姿勢だと私は受け止めている。また、法律政治学科のアドミッション・ポリシーが求める「社会現象への関心と行動力」も、生徒会での取り組みを通して身につけてきたものである。</a:t>
+              <a:t>この経験から私が学んだのは、ルールは一方的に押し付けるものではなく、異なる立場の人々が納得できるよう話し合ってつくるものだということである。貴学の建学の精神にある「積極進取の気概」と「教養と品格」は、自ら課題に向き合い、相手を尊重しながら合意を探る姿勢だと私は受け止めている。また、政経学部のアドミッション・ポリシーが求める「国内外の社会現象への強い関心と行動力」も、生徒会での取り組みを通して身につけてきたものである。</a:t>
             </a:r>
           </a:p>
         </p:txBody>
@@ -4601,7 +4601,7 @@
         </p:nvSpPr>
         <p:spPr>
           <a:xfrm>
-            <a:off x="704088" y="2894076"/>
+            <a:off x="704088" y="3116961"/>
             <a:ext cx="914400" cy="365760"/>
           </a:xfrm>
           <a:prstGeom prst="roundRect">
@@ -4657,8 +4657,8 @@
         </p:nvSpPr>
         <p:spPr>
           <a:xfrm>
-            <a:off x="1783080" y="2857500"/>
-            <a:ext cx="9674352" cy="946404"/>
+            <a:off x="1783080" y="3080385"/>
+            <a:ext cx="9674352" cy="723519"/>
           </a:xfrm>
           <a:prstGeom prst="rect">
             <a:avLst/>
@@ -4688,7 +4688,7 @@
                 <a:latin typeface="游ゴシック"/>
                 <a:ea typeface="游ゴシック"/>
               </a:rPr>
-              <a:t>貴学科では、憲法や行政法を通して、社会のルールがどのような原理に基づいてつくられているのかを理論的に学びたい。さらに、政治学の授業で合意形成の仕組みを学び、生徒会で得た経験を実践的な知識へと高めたい。加えて、ゼミでの議論を通して、異なる意見を持つ相手と論理的に話し合う力も伸ばしたい。法律と政治の両方を学べる貴学科の環境は、私の目標に最もふさわしいと考える。</a:t>
+              <a:t>貴学科では、憲法や行政法を通して、社会のルールがどのような原理に基づいてつくられているのかを理論的に学びたい。さらに、政治学の授業で合意形成の仕組みを学び、生徒会で得た経験を実践的な知識へと高めたい。法律と政治の両方を学べる貴学科の環境は、私の目標に最もふさわしいと考える。</a:t>
             </a:r>
           </a:p>
         </p:txBody>
@@ -5362,7 +5362,7 @@
                 <a:latin typeface="游ゴシック"/>
                 <a:ea typeface="游ゴシック"/>
               </a:rPr>
-              <a:t>この演習で軸にする言葉（建学の理念）</a:t>
+              <a:t>この演習で軸にする言葉（建学の理念・拓殖人材）</a:t>
             </a:r>
           </a:p>
         </p:txBody>
@@ -5471,14 +5471,14 @@
           <a:p>
             <a:pPr algn="ctr"/>
             <a:r>
-              <a:rPr sz="1500" b="1">
+              <a:rPr sz="1100" b="1">
                 <a:solidFill>
                   <a:srgbClr val="2C5F2D"/>
                 </a:solidFill>
                 <a:latin typeface="游ゴシック"/>
                 <a:ea typeface="游ゴシック"/>
               </a:rPr>
-              <a:t>あらゆる民族から敬慕される</a:t>
+              <a:t>あらゆる民族から敬慕されるに値する教養と品格</a:t>
             </a:r>
           </a:p>
         </p:txBody>
@@ -5536,7 +5536,7 @@
                 <a:latin typeface="游ゴシック"/>
                 <a:ea typeface="游ゴシック"/>
               </a:rPr>
-              <a:t>教養と品格</a:t>
+              <a:t>国際的な視野</a:t>
             </a:r>
           </a:p>
         </p:txBody>
@@ -5594,7 +5594,7 @@
                 <a:latin typeface="游ゴシック"/>
                 <a:ea typeface="游ゴシック"/>
               </a:rPr>
-              <a:t>国際的な視野</a:t>
+              <a:t>課題の発見と解決にチャレンジ</a:t>
             </a:r>
           </a:p>
         </p:txBody>
@@ -5652,7 +5652,7 @@
                 <a:latin typeface="游ゴシック"/>
                 <a:ea typeface="游ゴシック"/>
               </a:rPr>
-              <a:t>開拓の精神</a:t>
+              <a:t>拓殖人材</a:t>
             </a:r>
           </a:p>
         </p:txBody>
@@ -5806,7 +5806,7 @@
                 <a:latin typeface="游ゴシック"/>
                 <a:ea typeface="游ゴシック"/>
               </a:rPr>
-              <a:t>② 「アドミッション・ポリシー」＝グローバル化への関心</a:t>
+              <a:t>② 「アドミッション・ポリシー」＝グローバリゼーションへの興味</a:t>
             </a:r>
           </a:p>
           <a:p>
@@ -9395,7 +9395,7 @@
                 <a:latin typeface="游ゴシック"/>
                 <a:ea typeface="游ゴシック"/>
               </a:rPr>
-              <a:t>制度の分かりにくさに気づく／敬慕される教養と品格／AP「グローバル化への関心」</a:t>
+              <a:t>制度の分かりにくさに気づく／敬慕される教養と品格／AP「グローバリゼーションへの興味」</a:t>
             </a:r>
           </a:p>
         </p:txBody>
@@ -10129,7 +10129,7 @@
                 <a:latin typeface="游ゴシック"/>
                 <a:ea typeface="游ゴシック"/>
               </a:rPr>
-              <a:t>合計915字（序論138・本論①279・本論②220・本論③151・結論127）</a:t>
+              <a:t>合計947字（序論138・本論①279・本論②252・本論③151・結論127）</a:t>
             </a:r>
           </a:p>
         </p:txBody>
@@ -10815,7 +10815,7 @@
                 <a:latin typeface="游ゴシック"/>
                 <a:ea typeface="游ゴシック"/>
               </a:rPr>
-              <a:t>合計915字（序論138・本論①279・本論②220・本論③151・結論127）</a:t>
+              <a:t>合計947字（序論138・本論①279・本論②252・本論③151・結論127）</a:t>
             </a:r>
           </a:p>
         </p:txBody>
@@ -10963,7 +10963,7 @@
                 <a:latin typeface="游ゴシック"/>
                 <a:ea typeface="游ゴシック"/>
               </a:rPr>
-              <a:t>この経験を通して、言葉の壁だけでなく、制度や手続きの分かりにくさが、外国人住民の暮らしを難しくしていることに気づいた。貴学は、あらゆる民族から敬慕されるに値する教養と品格を備えた人材の育成を建学の理念としている。私は、相手の文化を尊重し、困っている人の立場に立って行動することこそ、この理念の実践だと考える。また、法律政治学科のアドミッション・ポリシーが求める「グローバル化への関心」と「行動力」も、ボランティアの中で育ててきたものである。</a:t>
+              <a:t>この経験を通して、言葉の壁だけでなく、制度や手続きの分かりにくさが、外国人住民の暮らしを難しくしていることに気づいた。貴学は、「積極進取の気概とあらゆる民族から敬慕されるに値する教養と品格を具えた有為の人材の育成」を建学の理念としている。私は、相手の文化を尊重し、困っている人の立場に立って行動することこそ、この理念の実践だと考える。また、法律政治学科のアドミッション・ポリシーが求める「グローバリゼーションへの興味」と「国内外の社会現象への強い関心と行動力」も、ボランティアの中で育ててきたものである。</a:t>
             </a:r>
           </a:p>
         </p:txBody>
@@ -11757,7 +11757,7 @@
                 <a:latin typeface="游ゴシック"/>
                 <a:ea typeface="游ゴシック"/>
               </a:rPr>
-              <a:t>・グローバル化への関心と論理的思考力</a:t>
+              <a:t>・グローバリゼーションへの興味と論理的思考力</a:t>
             </a:r>
           </a:p>
           <a:p>
@@ -11777,7 +11777,7 @@
                 <a:latin typeface="游ゴシック"/>
                 <a:ea typeface="游ゴシック"/>
               </a:rPr>
-              <a:t>・国内外の社会現象への関心と行動力</a:t>
+              <a:t>・国内外の社会現象への強い関心と行動力</a:t>
             </a:r>
           </a:p>
           <a:p>
@@ -11797,7 +11797,7 @@
                 <a:latin typeface="游ゴシック"/>
                 <a:ea typeface="游ゴシック"/>
               </a:rPr>
-              <a:t>・地域社会・グローバル社会を支える志</a:t>
+              <a:t>・地域社会やグローバル社会を支える志</a:t>
             </a:r>
           </a:p>
           <a:p>
@@ -11817,7 +11817,7 @@
                 <a:latin typeface="游ゴシック"/>
                 <a:ea typeface="游ゴシック"/>
               </a:rPr>
-              <a:t>・実社会の諸問題を的確に指摘し、解決する力</a:t>
+              <a:t>・実社会の諸問題を的確に指摘し、解決できる能力</a:t>
             </a:r>
           </a:p>
         </p:txBody>
@@ -17004,7 +17004,7 @@
                 <a:latin typeface="游ゴシック"/>
                 <a:ea typeface="游ゴシック"/>
               </a:rPr>
-              <a:t>合計928字（序論144・本論①307・本論②190・本論③128・結論159）</a:t>
+              <a:t>合計938字（序論146・本論①307・本論②198・本論③128・結論159）</a:t>
             </a:r>
           </a:p>
         </p:txBody>
@@ -17152,7 +17152,7 @@
                 <a:latin typeface="游ゴシック"/>
                 <a:ea typeface="游ゴシック"/>
               </a:rPr>
-              <a:t>私の強みは、身近な社会の問題に疑問を持ち、根拠を集めて考え、行動に移す力である。これは、法律政治学科のアドミッション・ポリシーが求める「論理的思考力」と「国内外の社会現象への関心と行動力」に重なるものだと考える。私はこの力を貴学科でさらに伸ばし、政治を若い世代にとって身近なものにしたい。</a:t>
+              <a:t>私の強みは、身近な社会の問題に疑問を持ち、根拠を集めて考え、行動に移す力である。これは、法律政治学科のアドミッション・ポリシーが求める「論理的思考力」と「国内外の社会現象への強い関心と行動力」に重なるものだと考える。私はこの力を貴学科でさらに伸ばし、政治を若い世代にとって身近なものにしたい。</a:t>
             </a:r>
           </a:p>
         </p:txBody>
@@ -17690,7 +17690,7 @@
                 <a:latin typeface="游ゴシック"/>
                 <a:ea typeface="游ゴシック"/>
               </a:rPr>
-              <a:t>合計928字（序論144・本論①307・本論②190・本論③128・結論159）</a:t>
+              <a:t>合計938字（序論146・本論①307・本論②198・本論③128・結論159）</a:t>
             </a:r>
           </a:p>
         </p:txBody>
@@ -17838,7 +17838,7 @@
                 <a:latin typeface="游ゴシック"/>
                 <a:ea typeface="游ゴシック"/>
               </a:rPr>
-              <a:t>この経験から、問題の原因をデータで確かめ、解決策を考えて実行することの大切さを学んだ。貴学の建学の精神にある「積極進取の気概」は、課題を前にして立ち止まらず、自ら動く姿勢だと私は理解している。模擬選挙の企画は、まさにその姿勢で取り組んだものである。また、政治に関心を持つ仲間を学校の中に増やせたことは、アドミッション・ポリシーにある「地域社会を支える志」の第一歩であったと考える。</a:t>
+              <a:t>この経験から、問題の原因をデータで確かめ、解決策を考えて実行することの大切さを学んだ。貴学の建学の精神にある「積極進取の気概」は、課題を前にして立ち止まらず、自ら動く姿勢だと私は理解している。模擬選挙の企画は、まさにその姿勢で取り組んだものである。また、政治に関心を持つ仲間を学校の中に増やせたことは、アドミッション・ポリシーにある「地域社会やグローバル社会を支える志」の第一歩であったと考える。</a:t>
             </a:r>
           </a:p>
         </p:txBody>
@@ -23309,7 +23309,7 @@
               </a:spcAft>
             </a:pPr>
             <a:r>
-              <a:rPr sz="1450" b="1">
+              <a:rPr sz="1250" b="1">
                 <a:solidFill>
                   <a:srgbClr val="2C5F2D"/>
                 </a:solidFill>
@@ -23329,14 +23329,14 @@
               </a:spcAft>
             </a:pPr>
             <a:r>
-              <a:rPr sz="1450" b="0">
+              <a:rPr sz="1250" b="0">
                 <a:solidFill>
                   <a:srgbClr val="23301F"/>
                 </a:solidFill>
                 <a:latin typeface="游ゴシック"/>
                 <a:ea typeface="游ゴシック"/>
               </a:rPr>
-              <a:t>建学の理念：「積極進取の気概とあらゆる民族から敬慕されるに値する教養と品格を具えた有為な人材の育成」（拓殖人材）。政経学部のAP：他者と協働しながら現場で課題に対処する意欲、グローバリゼーションへの関心、論理的思考力、社会現象への関心と行動力。留学・ボランティア等も評価。法律政治学科のAP：法律学・政治学の知識で実社会の問題を解決する力、地域・グローバル社会を支える志。</a:t>
+              <a:t>建学の理念：「積極進取の気概とあらゆる民族から敬慕されるに値する教養と品格を具えた有為の人材の育成」。めざす人材（拓殖人材）：国際的な視野を持ち、国内外の人々と協働して積極的に課題の発見と解決にチャレンジしていく。政経学部のAP：現前する課題に他者と協働の上、現場の第一線で対処しようとする意欲。グローバリゼーションへの興味と論理的思考力、国内外の社会現象への強い関心と行動力。学科のAP(3)：地域社会やグローバル社会を支える志 など。</a:t>
             </a:r>
           </a:p>
         </p:txBody>
@@ -24595,7 +24595,7 @@
                   <a:latin typeface="游ゴシック"/>
                   <a:ea typeface="游ゴシック"/>
                 </a:rPr>
-                <a:t>大学は「協働して問題を解決する人材」、学部・学科は「現場で課題に対処し解決する力」を求めている</a:t>
+                <a:t>大学は「課題の発見と解決にチャレンジ」、学部は「他者と協働し現場で課題に対処」する人を求める</a:t>
               </a:r>
             </a:p>
           </p:txBody>
@@ -27830,7 +27830,7 @@
                   <a:latin typeface="游ゴシック"/>
                   <a:ea typeface="游ゴシック"/>
                 </a:rPr>
-                <a:t>ルールは話し合ってつくる／積極進取・教養と品格／AP「関心と行動力」</a:t>
+                <a:t>ルールは話し合ってつくる／積極進取・教養と品格／AP「強い関心と行動力」</a:t>
               </a:r>
             </a:p>
           </p:txBody>

</xml_diff>